<commit_message>
docs(deck): Hook-Ausgang "1, 127, Timeout" nennt den Standard, mit onFailure block blockt er (#10044)
Beleg: code.claude.com/docs/en/hooks.md, Abschnitt "Block the action when a hook fails"
(onFailure "block" ab Claude Code v2.1.295), quellentreu wie 1840f9f.

- Hooks-Diagramm Folie 8: Beschriftung "Standard: läuft trotzdem (fail-open); mit onFailure block: blockt",
  Box etwas höher, kleinere Schrift für den langen Text
- Sprechernotiz Sicherheitsboden: "im Standard", Verweis auf onFailure block
- Deck mit tools/build_deck.py neu gebaut (13 Folien)

Co-Authored-By: Claude Sonnet 5.5 <noreply@anthropic.com>
</commit_message>
<xml_diff>
--- a/resources/media/claude-code-praxisbibliothek.pptx
+++ b/resources/media/claude-code-praxisbibliothek.pptx
@@ -1144,7 +1144,7 @@
           <a:lstStyle/>
           <a:p>
             <a:r>
-              <a:t>Neun Kapitel empfehlen wir allen, auch Fortgeschrittenen, mindestens zum Überfliegen. Das Wichtigste: Von den Exit-Codes blockt nur 2, ein abstürzender Hook lässt die Aktion durch. Und claude -p ohne --bare führt die Hooks eines fremden Repos aus.</a:t>
+              <a:t>Neun Kapitel empfehlen wir allen, auch Fortgeschrittenen, mindestens zum Überfliegen. Das Wichtigste: Von den Exit-Codes blockt nur 2, ein abstürzender Hook lässt die Aktion im Standard durch (mit onFailure block blockt er). Und claude -p ohne --bare führt die Hooks eines fremden Repos aus.</a:t>
             </a:r>
           </a:p>
         </p:txBody>
@@ -5860,7 +5860,7 @@
                 </a:solidFill>
                 <a:latin typeface="Calibri"/>
               </a:rPr>
-              <a:t>70</a:t>
+              <a:t>71</a:t>
             </a:r>
           </a:p>
         </p:txBody>
@@ -6000,7 +6000,7 @@
                 </a:solidFill>
                 <a:latin typeface="Calibri"/>
               </a:rPr>
-              <a:t>17 h</a:t>
+              <a:t>28 h</a:t>
             </a:r>
           </a:p>
         </p:txBody>
@@ -6166,7 +6166,7 @@
                 </a:solidFill>
                 <a:latin typeface="Calibri"/>
               </a:rPr>
-              <a:t>Session 4 · 10 Kapitel · Kern 0,5 h</a:t>
+              <a:t>Session 4 · 11 Kapitel · Kern 1,5 h</a:t>
             </a:r>
           </a:p>
         </p:txBody>
@@ -6341,7 +6341,7 @@
                 </a:solidFill>
                 <a:latin typeface="Calibri"/>
               </a:rPr>
-              <a:t>15 Min</a:t>
+              <a:t>25 Min</a:t>
             </a:r>
           </a:p>
         </p:txBody>
@@ -6446,7 +6446,7 @@
                 </a:solidFill>
                 <a:latin typeface="Calibri"/>
               </a:rPr>
-              <a:t>15 Min</a:t>
+              <a:t>25 Min</a:t>
             </a:r>
           </a:p>
         </p:txBody>
@@ -6551,7 +6551,7 @@
                 </a:solidFill>
                 <a:latin typeface="Calibri"/>
               </a:rPr>
-              <a:t>51 Min</a:t>
+              <a:t>85 Min</a:t>
             </a:r>
           </a:p>
         </p:txBody>
@@ -6656,7 +6656,7 @@
                 </a:solidFill>
                 <a:latin typeface="Calibri"/>
               </a:rPr>
-              <a:t>27 Min</a:t>
+              <a:t>45 Min</a:t>
             </a:r>
           </a:p>
         </p:txBody>
@@ -6726,7 +6726,7 @@
                 </a:solidFill>
                 <a:latin typeface="Consolas"/>
               </a:rPr>
-              <a:t>S4.8</a:t>
+              <a:t>S4.8, S4.11</a:t>
             </a:r>
           </a:p>
         </p:txBody>
@@ -6761,7 +6761,7 @@
                 </a:solidFill>
                 <a:latin typeface="Calibri"/>
               </a:rPr>
-              <a:t>25 Min</a:t>
+              <a:t>85 Min</a:t>
             </a:r>
           </a:p>
         </p:txBody>
@@ -6866,7 +6866,7 @@
                 </a:solidFill>
                 <a:latin typeface="Calibri"/>
               </a:rPr>
-              <a:t>33 Min</a:t>
+              <a:t>60 Min</a:t>
             </a:r>
           </a:p>
         </p:txBody>
@@ -10550,7 +10550,7 @@
                 </a:solidFill>
                 <a:latin typeface="Calibri"/>
               </a:rPr>
-              <a:t>70 Kapitel</a:t>
+              <a:t>71 Kapitel</a:t>
             </a:r>
           </a:p>
         </p:txBody>
@@ -14033,7 +14033,7 @@
                 </a:solidFill>
                 <a:latin typeface="Calibri"/>
               </a:rPr>
-              <a:t>1 Kapitel</a:t>
+              <a:t>2 Kapitel</a:t>
             </a:r>
           </a:p>
         </p:txBody>
@@ -15558,7 +15558,7 @@
                 </a:solidFill>
                 <a:latin typeface="Calibri"/>
               </a:rPr>
-              <a:t>Session 1 · 20 Kapitel · Kern 3,5 h</a:t>
+              <a:t>Session 1 · 20 Kapitel · Kern 4 h</a:t>
             </a:r>
           </a:p>
         </p:txBody>
@@ -15733,7 +15733,7 @@
                 </a:solidFill>
                 <a:latin typeface="Calibri"/>
               </a:rPr>
-              <a:t>48 Min</a:t>
+              <a:t>60 Min</a:t>
             </a:r>
           </a:p>
         </p:txBody>
@@ -15838,7 +15838,7 @@
                 </a:solidFill>
                 <a:latin typeface="Calibri"/>
               </a:rPr>
-              <a:t>30 Min</a:t>
+              <a:t>35 Min</a:t>
             </a:r>
           </a:p>
         </p:txBody>
@@ -16048,7 +16048,7 @@
                 </a:solidFill>
                 <a:latin typeface="Calibri"/>
               </a:rPr>
-              <a:t>72 Min</a:t>
+              <a:t>85 Min</a:t>
             </a:r>
           </a:p>
         </p:txBody>
@@ -16153,7 +16153,7 @@
                 </a:solidFill>
                 <a:latin typeface="Calibri"/>
               </a:rPr>
-              <a:t>42 Min</a:t>
+              <a:t>45 Min</a:t>
             </a:r>
           </a:p>
         </p:txBody>
@@ -16258,7 +16258,7 @@
                 </a:solidFill>
                 <a:latin typeface="Calibri"/>
               </a:rPr>
-              <a:t>48 Min</a:t>
+              <a:t>55 Min</a:t>
             </a:r>
           </a:p>
         </p:txBody>
@@ -16363,7 +16363,7 @@
                 </a:solidFill>
                 <a:latin typeface="Calibri"/>
               </a:rPr>
-              <a:t>15 Min</a:t>
+              <a:t>20 Min</a:t>
             </a:r>
           </a:p>
         </p:txBody>
@@ -17011,7 +17011,7 @@
                 </a:solidFill>
                 <a:latin typeface="Calibri"/>
               </a:rPr>
-              <a:t>Session 2 · 20 Kapitel · Kern 3 h</a:t>
+              <a:t>Session 2 · 20 Kapitel · Kern 5 h</a:t>
             </a:r>
           </a:p>
         </p:txBody>
@@ -17186,7 +17186,7 @@
                 </a:solidFill>
                 <a:latin typeface="Calibri"/>
               </a:rPr>
-              <a:t>69 Min</a:t>
+              <a:t>125 Min</a:t>
             </a:r>
           </a:p>
         </p:txBody>
@@ -17291,7 +17291,7 @@
                 </a:solidFill>
                 <a:latin typeface="Calibri"/>
               </a:rPr>
-              <a:t>72 Min</a:t>
+              <a:t>130 Min</a:t>
             </a:r>
           </a:p>
         </p:txBody>
@@ -17396,7 +17396,7 @@
                 </a:solidFill>
                 <a:latin typeface="Calibri"/>
               </a:rPr>
-              <a:t>40 Min</a:t>
+              <a:t>70 Min</a:t>
             </a:r>
           </a:p>
         </p:txBody>
@@ -17501,7 +17501,7 @@
                 </a:solidFill>
                 <a:latin typeface="Calibri"/>
               </a:rPr>
-              <a:t>91 Min</a:t>
+              <a:t>140 Min</a:t>
             </a:r>
           </a:p>
         </p:txBody>
@@ -17606,7 +17606,7 @@
                 </a:solidFill>
                 <a:latin typeface="Calibri"/>
               </a:rPr>
-              <a:t>18 Min</a:t>
+              <a:t>25 Min</a:t>
             </a:r>
           </a:p>
         </p:txBody>
@@ -17917,7 +17917,7 @@
         <p:spPr>
           <a:xfrm>
             <a:off x="6903720" y="4297680"/>
-            <a:ext cx="1508760" cy="960120"/>
+            <a:ext cx="1508760" cy="1188720"/>
           </a:xfrm>
           <a:prstGeom prst="roundRect">
             <a:avLst>
@@ -17965,7 +17965,7 @@
         <p:spPr>
           <a:xfrm>
             <a:off x="7013448" y="4297680"/>
-            <a:ext cx="1325880" cy="960120"/>
+            <a:ext cx="1325880" cy="1188720"/>
           </a:xfrm>
           <a:prstGeom prst="rect">
             <a:avLst/>
@@ -18048,7 +18048,7 @@
         <p:spPr>
           <a:xfrm>
             <a:off x="8522208" y="4297680"/>
-            <a:ext cx="1508760" cy="960120"/>
+            <a:ext cx="1508760" cy="1188720"/>
           </a:xfrm>
           <a:prstGeom prst="roundRect">
             <a:avLst>
@@ -18096,7 +18096,7 @@
         <p:spPr>
           <a:xfrm>
             <a:off x="8631936" y="4297680"/>
-            <a:ext cx="1325880" cy="960120"/>
+            <a:ext cx="1325880" cy="1188720"/>
           </a:xfrm>
           <a:prstGeom prst="rect">
             <a:avLst/>
@@ -18179,7 +18179,7 @@
         <p:spPr>
           <a:xfrm>
             <a:off x="10140696" y="4297680"/>
-            <a:ext cx="1508760" cy="960120"/>
+            <a:ext cx="1508760" cy="1188720"/>
           </a:xfrm>
           <a:prstGeom prst="roundRect">
             <a:avLst>
@@ -18227,7 +18227,7 @@
         <p:spPr>
           <a:xfrm>
             <a:off x="10250424" y="4297680"/>
-            <a:ext cx="1325880" cy="960120"/>
+            <a:ext cx="1325880" cy="1188720"/>
           </a:xfrm>
           <a:prstGeom prst="rect">
             <a:avLst/>
@@ -18254,13 +18254,13 @@
           <a:p>
             <a:pPr algn="l"/>
             <a:r>
-              <a:rPr sz="1400" b="0" i="0">
+              <a:rPr sz="1100" b="0" i="0">
                 <a:solidFill>
                   <a:srgbClr val="B4BEC8"/>
                 </a:solidFill>
                 <a:latin typeface="Calibri"/>
               </a:rPr>
-              <a:t>läuft trotzdem: fail-open</a:t>
+              <a:t>Standard: läuft trotzdem (fail-open); mit onFailure block: blockt</a:t>
             </a:r>
           </a:p>
         </p:txBody>
@@ -18273,7 +18273,7 @@
         </p:nvSpPr>
         <p:spPr>
           <a:xfrm>
-            <a:off x="6903720" y="5532120"/>
+            <a:off x="6903720" y="5669280"/>
             <a:ext cx="4846320" cy="731520"/>
           </a:xfrm>
           <a:prstGeom prst="rect">
@@ -18356,7 +18356,7 @@
                 </a:solidFill>
                 <a:latin typeface="Calibri"/>
               </a:rPr>
-              <a:t>Session 3 · 15 Kapitel · Kern 2,5 h</a:t>
+              <a:t>Session 3 · 15 Kapitel · Kern 5 h</a:t>
             </a:r>
           </a:p>
         </p:txBody>
@@ -18531,7 +18531,7 @@
                 </a:solidFill>
                 <a:latin typeface="Calibri"/>
               </a:rPr>
-              <a:t>70 Min</a:t>
+              <a:t>105 Min</a:t>
             </a:r>
           </a:p>
         </p:txBody>
@@ -18636,7 +18636,7 @@
                 </a:solidFill>
                 <a:latin typeface="Calibri"/>
               </a:rPr>
-              <a:t>57 Min</a:t>
+              <a:t>105 Min</a:t>
             </a:r>
           </a:p>
         </p:txBody>
@@ -18741,7 +18741,7 @@
                 </a:solidFill>
                 <a:latin typeface="Calibri"/>
               </a:rPr>
-              <a:t>30 Min</a:t>
+              <a:t>60 Min</a:t>
             </a:r>
           </a:p>
         </p:txBody>
@@ -18846,7 +18846,7 @@
                 </a:solidFill>
                 <a:latin typeface="Calibri"/>
               </a:rPr>
-              <a:t>42 Min</a:t>
+              <a:t>75 Min</a:t>
             </a:r>
           </a:p>
         </p:txBody>
@@ -18951,7 +18951,7 @@
                 </a:solidFill>
                 <a:latin typeface="Calibri"/>
               </a:rPr>
-              <a:t>15 Min</a:t>
+              <a:t>25 Min</a:t>
             </a:r>
           </a:p>
         </p:txBody>

</xml_diff>

<commit_message>
fix(deck): Folie 8 wieder mit 14 pt, Schlusssatz nennt den Standard (#10044)
Der Hook-Ausgang-Text hatte 11 pt und riss test_deck_is_built_from_the_catalog_with_readable_type.
Text gekürzt, Boxen höher, alles 14 pt; Schlusssatz wie S2.8 (1840f9f): "Im Standard ...".

Co-Authored-By: Claude Sonnet 5.5 <noreply@anthropic.com>
</commit_message>
<xml_diff>
--- a/resources/media/claude-code-praxisbibliothek.pptx
+++ b/resources/media/claude-code-praxisbibliothek.pptx
@@ -17917,7 +17917,7 @@
         <p:spPr>
           <a:xfrm>
             <a:off x="6903720" y="4297680"/>
-            <a:ext cx="1508760" cy="1188720"/>
+            <a:ext cx="1508760" cy="1828800"/>
           </a:xfrm>
           <a:prstGeom prst="roundRect">
             <a:avLst>
@@ -17965,7 +17965,7 @@
         <p:spPr>
           <a:xfrm>
             <a:off x="7013448" y="4297680"/>
-            <a:ext cx="1325880" cy="1188720"/>
+            <a:ext cx="1325880" cy="1828800"/>
           </a:xfrm>
           <a:prstGeom prst="rect">
             <a:avLst/>
@@ -18048,7 +18048,7 @@
         <p:spPr>
           <a:xfrm>
             <a:off x="8522208" y="4297680"/>
-            <a:ext cx="1508760" cy="1188720"/>
+            <a:ext cx="1508760" cy="1828800"/>
           </a:xfrm>
           <a:prstGeom prst="roundRect">
             <a:avLst>
@@ -18096,7 +18096,7 @@
         <p:spPr>
           <a:xfrm>
             <a:off x="8631936" y="4297680"/>
-            <a:ext cx="1325880" cy="1188720"/>
+            <a:ext cx="1325880" cy="1828800"/>
           </a:xfrm>
           <a:prstGeom prst="rect">
             <a:avLst/>
@@ -18179,7 +18179,7 @@
         <p:spPr>
           <a:xfrm>
             <a:off x="10140696" y="4297680"/>
-            <a:ext cx="1508760" cy="1188720"/>
+            <a:ext cx="1508760" cy="1828800"/>
           </a:xfrm>
           <a:prstGeom prst="roundRect">
             <a:avLst>
@@ -18227,7 +18227,7 @@
         <p:spPr>
           <a:xfrm>
             <a:off x="10250424" y="4297680"/>
-            <a:ext cx="1325880" cy="1188720"/>
+            <a:ext cx="1325880" cy="1828800"/>
           </a:xfrm>
           <a:prstGeom prst="rect">
             <a:avLst/>
@@ -18254,13 +18254,13 @@
           <a:p>
             <a:pPr algn="l"/>
             <a:r>
-              <a:rPr sz="1100" b="0" i="0">
+              <a:rPr sz="1400" b="0" i="0">
                 <a:solidFill>
                   <a:srgbClr val="B4BEC8"/>
                 </a:solidFill>
                 <a:latin typeface="Calibri"/>
               </a:rPr>
-              <a:t>Standard: läuft trotzdem (fail-open); mit onFailure block: blockt</a:t>
+              <a:t>Standard: läuft (fail-open); mit onFailure block: blockt</a:t>
             </a:r>
           </a:p>
         </p:txBody>
@@ -18273,8 +18273,8 @@
         </p:nvSpPr>
         <p:spPr>
           <a:xfrm>
-            <a:off x="6903720" y="5669280"/>
-            <a:ext cx="4846320" cy="731520"/>
+            <a:off x="6903720" y="6172200"/>
+            <a:ext cx="4846320" cy="640080"/>
           </a:xfrm>
           <a:prstGeom prst="rect">
             <a:avLst/>
@@ -18295,7 +18295,7 @@
                 </a:solidFill>
                 <a:latin typeface="Calibri"/>
               </a:rPr>
-              <a:t>Ein kaputter Schutz-Hook ist ein offener Schutz-Hook.</a:t>
+              <a:t>Im Standard ist ein kaputter Schutz-Hook ein offener Schutz-Hook.</a:t>
             </a:r>
           </a:p>
         </p:txBody>

</xml_diff>